<commit_message>
Add project report and presentation
</commit_message>
<xml_diff>
--- a/docs/project_presentation.pptx
+++ b/docs/project_presentation.pptx
@@ -3181,28 +3181,40 @@
       </p:sp>
       <p:pic>
         <p:nvPicPr>
-          <p:cNvPr id="3" name="Picture 2" descr="uml_activity_diagram.png"/>
+          <p:cNvPr id="3" name="Picture Placeholder 2" descr="uml_activity_diagram.png"/>
           <p:cNvPicPr>
-            <a:picLocks noChangeAspect="1"/>
+            <a:picLocks noGrp="1" noChangeAspect="1"/>
           </p:cNvPicPr>
-          <p:nvPr/>
+          <p:nvPr>
+            <p:ph type="pic" idx="1"/>
+          </p:nvPr>
         </p:nvPicPr>
         <p:blipFill>
           <a:blip r:embed="rId2"/>
+          <a:srcRect l="12500" r="12500"/>
           <a:stretch>
             <a:fillRect/>
           </a:stretch>
         </p:blipFill>
-        <p:spPr>
-          <a:xfrm>
-            <a:off x="914400" y="1371600"/>
-            <a:ext cx="7315200" cy="4114800"/>
-          </a:xfrm>
-          <a:prstGeom prst="rect">
-            <a:avLst/>
-          </a:prstGeom>
-        </p:spPr>
+        <p:spPr/>
       </p:pic>
+      <p:sp>
+        <p:nvSpPr>
+          <p:cNvPr id="4" name="Text Placeholder 3"/>
+          <p:cNvSpPr>
+            <a:spLocks noGrp="1"/>
+          </p:cNvSpPr>
+          <p:nvPr>
+            <p:ph type="body" idx="2" sz="half"/>
+          </p:nvPr>
+        </p:nvSpPr>
+        <p:spPr/>
+        <p:txBody>
+          <a:bodyPr/>
+          <a:lstStyle/>
+          <a:p/>
+        </p:txBody>
+      </p:sp>
     </p:spTree>
   </p:cSld>
   <p:clrMapOvr>
@@ -3244,28 +3256,40 @@
       </p:sp>
       <p:pic>
         <p:nvPicPr>
-          <p:cNvPr id="3" name="Picture 2" descr="uml_sequence_diagram.png"/>
+          <p:cNvPr id="3" name="Picture Placeholder 2" descr="uml_sequence_diagram.png"/>
           <p:cNvPicPr>
-            <a:picLocks noChangeAspect="1"/>
+            <a:picLocks noGrp="1" noChangeAspect="1"/>
           </p:cNvPicPr>
-          <p:nvPr/>
+          <p:nvPr>
+            <p:ph type="pic" idx="1"/>
+          </p:nvPr>
         </p:nvPicPr>
         <p:blipFill>
           <a:blip r:embed="rId2"/>
+          <a:srcRect l="12500" r="12500"/>
           <a:stretch>
             <a:fillRect/>
           </a:stretch>
         </p:blipFill>
-        <p:spPr>
-          <a:xfrm>
-            <a:off x="914400" y="1371600"/>
-            <a:ext cx="7315200" cy="4114800"/>
-          </a:xfrm>
-          <a:prstGeom prst="rect">
-            <a:avLst/>
-          </a:prstGeom>
-        </p:spPr>
+        <p:spPr/>
       </p:pic>
+      <p:sp>
+        <p:nvSpPr>
+          <p:cNvPr id="4" name="Text Placeholder 3"/>
+          <p:cNvSpPr>
+            <a:spLocks noGrp="1"/>
+          </p:cNvSpPr>
+          <p:nvPr>
+            <p:ph type="body" idx="2" sz="half"/>
+          </p:nvPr>
+        </p:nvSpPr>
+        <p:spPr/>
+        <p:txBody>
+          <a:bodyPr/>
+          <a:lstStyle/>
+          <a:p/>
+        </p:txBody>
+      </p:sp>
     </p:spTree>
   </p:cSld>
   <p:clrMapOvr>
@@ -3298,6 +3322,27 @@
         <p:txBody>
           <a:bodyPr/>
           <a:lstStyle/>
+          <a:p>
+            <a:r>
+              <a:t>1. Process Model Selection and Justification</a:t>
+            </a:r>
+          </a:p>
+        </p:txBody>
+      </p:sp>
+      <p:sp>
+        <p:nvSpPr>
+          <p:cNvPr id="3" name="Content Placeholder 2"/>
+          <p:cNvSpPr>
+            <a:spLocks noGrp="1"/>
+          </p:cNvSpPr>
+          <p:nvPr>
+            <p:ph idx="1"/>
+          </p:nvPr>
+        </p:nvSpPr>
+        <p:spPr/>
+        <p:txBody>
+          <a:bodyPr/>
+          <a:lstStyle/>
           <a:p/>
           <a:p>
             <a:pPr>
@@ -3323,23 +3368,6 @@
               <a:t>Evidence from the project: iterative module delivery, seed data updates, sprint-style feature additions, and SPI adjustments.</a:t>
             </a:r>
           </a:p>
-        </p:txBody>
-      </p:sp>
-      <p:sp>
-        <p:nvSpPr>
-          <p:cNvPr id="3" name="Content Placeholder 2"/>
-          <p:cNvSpPr>
-            <a:spLocks noGrp="1"/>
-          </p:cNvSpPr>
-          <p:nvPr>
-            <p:ph idx="1"/>
-          </p:nvPr>
-        </p:nvSpPr>
-        <p:spPr/>
-        <p:txBody>
-          <a:bodyPr/>
-          <a:lstStyle/>
-          <a:p/>
         </p:txBody>
       </p:sp>
     </p:spTree>
@@ -3374,6 +3402,27 @@
         <p:txBody>
           <a:bodyPr/>
           <a:lstStyle/>
+          <a:p>
+            <a:r>
+              <a:t>2. Software Process Improvement (SPI)</a:t>
+            </a:r>
+          </a:p>
+        </p:txBody>
+      </p:sp>
+      <p:sp>
+        <p:nvSpPr>
+          <p:cNvPr id="3" name="Content Placeholder 2"/>
+          <p:cNvSpPr>
+            <a:spLocks noGrp="1"/>
+          </p:cNvSpPr>
+          <p:nvPr>
+            <p:ph idx="1"/>
+          </p:nvPr>
+        </p:nvSpPr>
+        <p:spPr/>
+        <p:txBody>
+          <a:bodyPr/>
+          <a:lstStyle/>
           <a:p/>
           <a:p>
             <a:pPr>
@@ -3399,23 +3448,6 @@
               <a:t>Project outcome: more maintainable code, improved validation, and a stronger QA workflow.</a:t>
             </a:r>
           </a:p>
-        </p:txBody>
-      </p:sp>
-      <p:sp>
-        <p:nvSpPr>
-          <p:cNvPr id="3" name="Content Placeholder 2"/>
-          <p:cNvSpPr>
-            <a:spLocks noGrp="1"/>
-          </p:cNvSpPr>
-          <p:nvPr>
-            <p:ph idx="1"/>
-          </p:nvPr>
-        </p:nvSpPr>
-        <p:spPr/>
-        <p:txBody>
-          <a:bodyPr/>
-          <a:lstStyle/>
-          <a:p/>
         </p:txBody>
       </p:sp>
     </p:spTree>
@@ -3450,6 +3482,27 @@
         <p:txBody>
           <a:bodyPr/>
           <a:lstStyle/>
+          <a:p>
+            <a:r>
+              <a:t>3. Version Control Implementation</a:t>
+            </a:r>
+          </a:p>
+        </p:txBody>
+      </p:sp>
+      <p:sp>
+        <p:nvSpPr>
+          <p:cNvPr id="3" name="Content Placeholder 2"/>
+          <p:cNvSpPr>
+            <a:spLocks noGrp="1"/>
+          </p:cNvSpPr>
+          <p:nvPr>
+            <p:ph idx="1"/>
+          </p:nvPr>
+        </p:nvSpPr>
+        <p:spPr/>
+        <p:txBody>
+          <a:bodyPr/>
+          <a:lstStyle/>
           <a:p/>
           <a:p>
             <a:pPr>
@@ -3475,23 +3528,6 @@
               <a:t>Academic justification: demonstrates version tracking and release management concepts.</a:t>
             </a:r>
           </a:p>
-        </p:txBody>
-      </p:sp>
-      <p:sp>
-        <p:nvSpPr>
-          <p:cNvPr id="3" name="Content Placeholder 2"/>
-          <p:cNvSpPr>
-            <a:spLocks noGrp="1"/>
-          </p:cNvSpPr>
-          <p:nvPr>
-            <p:ph idx="1"/>
-          </p:nvPr>
-        </p:nvSpPr>
-        <p:spPr/>
-        <p:txBody>
-          <a:bodyPr/>
-          <a:lstStyle/>
-          <a:p/>
         </p:txBody>
       </p:sp>
     </p:spTree>
@@ -3526,6 +3562,27 @@
         <p:txBody>
           <a:bodyPr/>
           <a:lstStyle/>
+          <a:p>
+            <a:r>
+              <a:t>4. Lehman’s Law Justification</a:t>
+            </a:r>
+          </a:p>
+        </p:txBody>
+      </p:sp>
+      <p:sp>
+        <p:nvSpPr>
+          <p:cNvPr id="3" name="Content Placeholder 2"/>
+          <p:cNvSpPr>
+            <a:spLocks noGrp="1"/>
+          </p:cNvSpPr>
+          <p:nvPr>
+            <p:ph idx="1"/>
+          </p:nvPr>
+        </p:nvSpPr>
+        <p:spPr/>
+        <p:txBody>
+          <a:bodyPr/>
+          <a:lstStyle/>
           <a:p/>
           <a:p>
             <a:pPr>
@@ -3551,23 +3608,6 @@
               <a:t>Complexity management: modular architecture and refactoring to keep growth sustainable.</a:t>
             </a:r>
           </a:p>
-        </p:txBody>
-      </p:sp>
-      <p:sp>
-        <p:nvSpPr>
-          <p:cNvPr id="3" name="Content Placeholder 2"/>
-          <p:cNvSpPr>
-            <a:spLocks noGrp="1"/>
-          </p:cNvSpPr>
-          <p:nvPr>
-            <p:ph idx="1"/>
-          </p:nvPr>
-        </p:nvSpPr>
-        <p:spPr/>
-        <p:txBody>
-          <a:bodyPr/>
-          <a:lstStyle/>
-          <a:p/>
         </p:txBody>
       </p:sp>
     </p:spTree>
@@ -3602,6 +3642,27 @@
         <p:txBody>
           <a:bodyPr/>
           <a:lstStyle/>
+          <a:p>
+            <a:r>
+              <a:t>5. Deployment Management</a:t>
+            </a:r>
+          </a:p>
+        </p:txBody>
+      </p:sp>
+      <p:sp>
+        <p:nvSpPr>
+          <p:cNvPr id="3" name="Content Placeholder 2"/>
+          <p:cNvSpPr>
+            <a:spLocks noGrp="1"/>
+          </p:cNvSpPr>
+          <p:nvPr>
+            <p:ph idx="1"/>
+          </p:nvPr>
+        </p:nvSpPr>
+        <p:spPr/>
+        <p:txBody>
+          <a:bodyPr/>
+          <a:lstStyle/>
           <a:p/>
           <a:p>
             <a:pPr>
@@ -3627,23 +3688,6 @@
               <a:t>If applicable: desktop shortcut creation, configuration file generation, and a repeatable build process.</a:t>
             </a:r>
           </a:p>
-        </p:txBody>
-      </p:sp>
-      <p:sp>
-        <p:nvSpPr>
-          <p:cNvPr id="3" name="Content Placeholder 2"/>
-          <p:cNvSpPr>
-            <a:spLocks noGrp="1"/>
-          </p:cNvSpPr>
-          <p:nvPr>
-            <p:ph idx="1"/>
-          </p:nvPr>
-        </p:nvSpPr>
-        <p:spPr/>
-        <p:txBody>
-          <a:bodyPr/>
-          <a:lstStyle/>
-          <a:p/>
         </p:txBody>
       </p:sp>
     </p:spTree>
@@ -3678,6 +3722,27 @@
         <p:txBody>
           <a:bodyPr/>
           <a:lstStyle/>
+          <a:p>
+            <a:r>
+              <a:t>6. Refactoring and Legacy Removal</a:t>
+            </a:r>
+          </a:p>
+        </p:txBody>
+      </p:sp>
+      <p:sp>
+        <p:nvSpPr>
+          <p:cNvPr id="3" name="Content Placeholder 2"/>
+          <p:cNvSpPr>
+            <a:spLocks noGrp="1"/>
+          </p:cNvSpPr>
+          <p:nvPr>
+            <p:ph idx="1"/>
+          </p:nvPr>
+        </p:nvSpPr>
+        <p:spPr/>
+        <p:txBody>
+          <a:bodyPr/>
+          <a:lstStyle/>
           <a:p/>
           <a:p>
             <a:pPr>
@@ -3703,23 +3768,6 @@
               <a:t>Benefits: easier maintenance, improved readability, and better testing.</a:t>
             </a:r>
           </a:p>
-        </p:txBody>
-      </p:sp>
-      <p:sp>
-        <p:nvSpPr>
-          <p:cNvPr id="3" name="Content Placeholder 2"/>
-          <p:cNvSpPr>
-            <a:spLocks noGrp="1"/>
-          </p:cNvSpPr>
-          <p:nvPr>
-            <p:ph idx="1"/>
-          </p:nvPr>
-        </p:nvSpPr>
-        <p:spPr/>
-        <p:txBody>
-          <a:bodyPr/>
-          <a:lstStyle/>
-          <a:p/>
         </p:txBody>
       </p:sp>
     </p:spTree>
@@ -3763,28 +3811,40 @@
       </p:sp>
       <p:pic>
         <p:nvPicPr>
-          <p:cNvPr id="3" name="Picture 2" descr="uml_use_case.png"/>
+          <p:cNvPr id="3" name="Picture Placeholder 2" descr="uml_use_case.png"/>
           <p:cNvPicPr>
-            <a:picLocks noChangeAspect="1"/>
+            <a:picLocks noGrp="1" noChangeAspect="1"/>
           </p:cNvPicPr>
-          <p:nvPr/>
+          <p:nvPr>
+            <p:ph type="pic" idx="1"/>
+          </p:nvPr>
         </p:nvPicPr>
         <p:blipFill>
           <a:blip r:embed="rId2"/>
+          <a:srcRect l="12500" r="12500"/>
           <a:stretch>
             <a:fillRect/>
           </a:stretch>
         </p:blipFill>
-        <p:spPr>
-          <a:xfrm>
-            <a:off x="914400" y="1371600"/>
-            <a:ext cx="7315200" cy="4114800"/>
-          </a:xfrm>
-          <a:prstGeom prst="rect">
-            <a:avLst/>
-          </a:prstGeom>
-        </p:spPr>
+        <p:spPr/>
       </p:pic>
+      <p:sp>
+        <p:nvSpPr>
+          <p:cNvPr id="4" name="Text Placeholder 3"/>
+          <p:cNvSpPr>
+            <a:spLocks noGrp="1"/>
+          </p:cNvSpPr>
+          <p:nvPr>
+            <p:ph type="body" idx="2" sz="half"/>
+          </p:nvPr>
+        </p:nvSpPr>
+        <p:spPr/>
+        <p:txBody>
+          <a:bodyPr/>
+          <a:lstStyle/>
+          <a:p/>
+        </p:txBody>
+      </p:sp>
     </p:spTree>
   </p:cSld>
   <p:clrMapOvr>
@@ -3826,28 +3886,40 @@
       </p:sp>
       <p:pic>
         <p:nvPicPr>
-          <p:cNvPr id="3" name="Picture 2" descr="uml_class_diagram.png"/>
+          <p:cNvPr id="3" name="Picture Placeholder 2" descr="uml_class_diagram.png"/>
           <p:cNvPicPr>
-            <a:picLocks noChangeAspect="1"/>
+            <a:picLocks noGrp="1" noChangeAspect="1"/>
           </p:cNvPicPr>
-          <p:nvPr/>
+          <p:nvPr>
+            <p:ph type="pic" idx="1"/>
+          </p:nvPr>
         </p:nvPicPr>
         <p:blipFill>
           <a:blip r:embed="rId2"/>
+          <a:srcRect l="12500" r="12500"/>
           <a:stretch>
             <a:fillRect/>
           </a:stretch>
         </p:blipFill>
-        <p:spPr>
-          <a:xfrm>
-            <a:off x="914400" y="1371600"/>
-            <a:ext cx="7315200" cy="4114800"/>
-          </a:xfrm>
-          <a:prstGeom prst="rect">
-            <a:avLst/>
-          </a:prstGeom>
-        </p:spPr>
+        <p:spPr/>
       </p:pic>
+      <p:sp>
+        <p:nvSpPr>
+          <p:cNvPr id="4" name="Text Placeholder 3"/>
+          <p:cNvSpPr>
+            <a:spLocks noGrp="1"/>
+          </p:cNvSpPr>
+          <p:nvPr>
+            <p:ph type="body" idx="2" sz="half"/>
+          </p:nvPr>
+        </p:nvSpPr>
+        <p:spPr/>
+        <p:txBody>
+          <a:bodyPr/>
+          <a:lstStyle/>
+          <a:p/>
+        </p:txBody>
+      </p:sp>
     </p:spTree>
   </p:cSld>
   <p:clrMapOvr>

</xml_diff>